<commit_message>
Explain algorithm discussion slide in plain language
</commit_message>
<xml_diff>
--- a/docs/汇报/算法实现方案/算法实现_讨论版_可编辑.pptx
+++ b/docs/汇报/算法实现方案/算法实现_讨论版_可编辑.pptx
@@ -500,6 +500,47 @@
         <p:txBody>
           <a:bodyPr/>
           <a:lstStyle/>
+          <a:p>
+            <a:r>
+              <a:t>易懂版讲解：</a:t>
+            </a:r>
+          </a:p>
+          <a:p>
+            <a:r>
+              <a:t>1. 比较正常水平：先了解健康工具在这个转速和负载下通常是什么样，再看当前信号与它有多大差异。</a:t>
+            </a:r>
+          </a:p>
+          <a:p>
+            <a:r>
+              <a:t>2. 结合数据质量：三种传感器一起参考，利用已有质量分数调整各通道的贡献，缺失通道不参与融合。这一步不表示模型已独立识别所有传感器异常。</a:t>
+            </a:r>
+          </a:p>
+          <a:p>
+            <a:r>
+              <a:t>3. 观察连续变化：把前后多次测量联系起来，分析信号如何变化。对应Transformer关联历史窗口，LSTM汇总变化趋势；两者合并为通俗的一个步骤，并未删除模型层。</a:t>
+            </a:r>
+          </a:p>
+          <a:p>
+            <a:r>
+              <a:t>4. 输出仿真结果：模型分别估计状态、健康程度和仿真寿命范围，送到网页展示与告警流程。不能把仿真寿命说成已验证的真实工具寿命。</a:t>
+            </a:r>
+          </a:p>
+          <a:p>
+            <a:r>
+              <a:t>页面中的负载例子是对工况校正目的的说明，不是模型已经逐项验证的现场规则；持续越阈值告警属于后续逻辑。</a:t>
+            </a:r>
+          </a:p>
+          <a:p>
+            <a:r>
+              <a:t>可直接口述：我先让算法参考当前转速和负载，比较信号与正常水平的差异；再结合三种传感器和数据质量，观察连续变化，最后给出状态与健康程度等仿真结果。目前完成了流程演示，真实工具的健康等级与寿命还需要实测验证。</a:t>
+            </a:r>
+          </a:p>
+          <a:p/>
+          <a:p>
+            <a:r>
+              <a:t>原技术说明保留在备注，供老师追问结构时参考：</a:t>
+            </a:r>
+          </a:p>
           <a:p>
             <a:r>
               <a:t>本页汇报已有代码的两条模型路径，两条分别训练，不能作为同一个多模态模型的联合验证结果。页面中“仿真模型”与“公开数据预验证”均为当前已实现代码，“下一步”为计划。</a:t>
@@ -3607,7 +3648,7 @@
                 <a:latin typeface="Noto Sans CJK SC"/>
                 <a:ea typeface="Noto Sans CJK SC"/>
               </a:rPr>
-              <a:t>算法实现与验证进度</a:t>
+              <a:t>算法如何判断工具状态</a:t>
             </a:r>
           </a:p>
         </p:txBody>
@@ -3620,8 +3661,8 @@
         </p:nvSpPr>
         <p:spPr>
           <a:xfrm>
-            <a:off x="731520" y="1298448"/>
-            <a:ext cx="10725912" cy="384048"/>
+            <a:off x="731520" y="1261872"/>
+            <a:ext cx="10725912" cy="393192"/>
           </a:xfrm>
           <a:prstGeom prst="rect">
             <a:avLst/>
@@ -3653,7 +3694,7 @@
                 <a:latin typeface="Noto Sans CJK SC"/>
                 <a:ea typeface="Noto Sans CJK SC"/>
               </a:rPr>
-              <a:t>现有仿真模型：多源健康与寿命演示</a:t>
+              <a:t>现有仿真 Demo 的处理思路</a:t>
             </a:r>
           </a:p>
         </p:txBody>
@@ -3666,8 +3707,8 @@
         </p:nvSpPr>
         <p:spPr>
           <a:xfrm>
-            <a:off x="731520" y="1801368"/>
-            <a:ext cx="10725912" cy="484632"/>
+            <a:off x="731520" y="1810512"/>
+            <a:ext cx="10725912" cy="585216"/>
           </a:xfrm>
           <a:prstGeom prst="roundRect">
             <a:avLst/>
@@ -3709,8 +3750,8 @@
         </p:nvSpPr>
         <p:spPr>
           <a:xfrm>
-            <a:off x="914400" y="1828800"/>
-            <a:ext cx="10360152" cy="429768"/>
+            <a:off x="914400" y="1847088"/>
+            <a:ext cx="10360152" cy="512064"/>
           </a:xfrm>
           <a:prstGeom prst="rect">
             <a:avLst/>
@@ -3742,7 +3783,7 @@
                 <a:latin typeface="Noto Sans CJK SC"/>
                 <a:ea typeface="Noto Sans CJK SC"/>
               </a:rPr>
-              <a:t>输入：振动／电流／温度特征＋转速／负载＋传感器质量</a:t>
+              <a:t>输入：振动、电流、温度的变化，以及转速、负载和数据质量</a:t>
             </a:r>
           </a:p>
         </p:txBody>
@@ -3755,8 +3796,769 @@
         </p:nvSpPr>
         <p:spPr>
           <a:xfrm>
-            <a:off x="731520" y="2487168"/>
-            <a:ext cx="1965960" cy="1051560"/>
+            <a:off x="731520" y="2779776"/>
+            <a:ext cx="2468880" cy="1399032"/>
+          </a:xfrm>
+          <a:prstGeom prst="roundRect">
+            <a:avLst/>
+          </a:prstGeom>
+          <a:solidFill>
+            <a:srgbClr val="E5F2F1"/>
+          </a:solidFill>
+          <a:ln>
+            <a:noFill/>
+          </a:ln>
+        </p:spPr>
+        <p:style>
+          <a:lnRef idx="1">
+            <a:schemeClr val="accent1"/>
+          </a:lnRef>
+          <a:fillRef idx="3">
+            <a:schemeClr val="accent1"/>
+          </a:fillRef>
+          <a:effectRef idx="2">
+            <a:schemeClr val="accent1"/>
+          </a:effectRef>
+          <a:fontRef idx="minor">
+            <a:schemeClr val="lt1"/>
+          </a:fontRef>
+        </p:style>
+        <p:txBody>
+          <a:bodyPr rtlCol="0" anchor="ctr"/>
+          <a:lstStyle/>
+          <a:p>
+            <a:pPr algn="ctr"/>
+          </a:p>
+        </p:txBody>
+      </p:sp>
+      <p:sp>
+        <p:nvSpPr>
+          <p:cNvPr id="7" name="TextBox 6"/>
+          <p:cNvSpPr txBox="1"/>
+          <p:nvPr/>
+        </p:nvSpPr>
+        <p:spPr>
+          <a:xfrm>
+            <a:off x="795528" y="2907792"/>
+            <a:ext cx="2340864" cy="393192"/>
+          </a:xfrm>
+          <a:prstGeom prst="rect">
+            <a:avLst/>
+          </a:prstGeom>
+          <a:noFill/>
+        </p:spPr>
+        <p:txBody>
+          <a:bodyPr wrap="square" lIns="32004" rIns="32004" tIns="4572" bIns="4572" anchor="ctr">
+            <a:spAutoFit/>
+          </a:bodyPr>
+          <a:lstStyle/>
+          <a:p>
+            <a:pPr algn="ctr">
+              <a:lnSpc>
+                <a:spcPct val="104000"/>
+              </a:lnSpc>
+              <a:spcBef>
+                <a:spcPts val="0"/>
+              </a:spcBef>
+              <a:spcAft>
+                <a:spcPts val="0"/>
+              </a:spcAft>
+            </a:pPr>
+            <a:r>
+              <a:rPr sz="2300" b="1">
+                <a:solidFill>
+                  <a:srgbClr val="147E84"/>
+                </a:solidFill>
+                <a:latin typeface="Noto Sans CJK SC"/>
+                <a:ea typeface="Noto Sans CJK SC"/>
+              </a:rPr>
+              <a:t>比较正常水平</a:t>
+            </a:r>
+          </a:p>
+        </p:txBody>
+      </p:sp>
+      <p:sp>
+        <p:nvSpPr>
+          <p:cNvPr id="8" name="TextBox 7"/>
+          <p:cNvSpPr txBox="1"/>
+          <p:nvPr/>
+        </p:nvSpPr>
+        <p:spPr>
+          <a:xfrm>
+            <a:off x="795528" y="3392424"/>
+            <a:ext cx="2340864" cy="630936"/>
+          </a:xfrm>
+          <a:prstGeom prst="rect">
+            <a:avLst/>
+          </a:prstGeom>
+          <a:noFill/>
+        </p:spPr>
+        <p:txBody>
+          <a:bodyPr wrap="square" lIns="32004" rIns="32004" tIns="4572" bIns="4572" anchor="ctr">
+            <a:spAutoFit/>
+          </a:bodyPr>
+          <a:lstStyle/>
+          <a:p>
+            <a:pPr algn="ctr">
+              <a:lnSpc>
+                <a:spcPct val="104000"/>
+              </a:lnSpc>
+              <a:spcBef>
+                <a:spcPts val="0"/>
+              </a:spcBef>
+              <a:spcAft>
+                <a:spcPts val="0"/>
+              </a:spcAft>
+            </a:pPr>
+            <a:r>
+              <a:rPr sz="2100" b="0">
+                <a:solidFill>
+                  <a:srgbClr val="243E50"/>
+                </a:solidFill>
+                <a:latin typeface="Noto Sans CJK SC"/>
+                <a:ea typeface="Noto Sans CJK SC"/>
+              </a:rPr>
+              <a:t>参考转速与负载</a:t>
+            </a:r>
+          </a:p>
+          <a:p>
+            <a:pPr algn="ctr">
+              <a:lnSpc>
+                <a:spcPct val="104000"/>
+              </a:lnSpc>
+              <a:spcBef>
+                <a:spcPts val="0"/>
+              </a:spcBef>
+              <a:spcAft>
+                <a:spcPts val="0"/>
+              </a:spcAft>
+            </a:pPr>
+            <a:r>
+              <a:rPr sz="2100" b="0">
+                <a:solidFill>
+                  <a:srgbClr val="243E50"/>
+                </a:solidFill>
+                <a:latin typeface="Noto Sans CJK SC"/>
+                <a:ea typeface="Noto Sans CJK SC"/>
+              </a:rPr>
+              <a:t>对比正常信号</a:t>
+            </a:r>
+          </a:p>
+        </p:txBody>
+      </p:sp>
+      <p:sp>
+        <p:nvSpPr>
+          <p:cNvPr id="9" name="Right Arrow 8"/>
+          <p:cNvSpPr/>
+          <p:nvPr/>
+        </p:nvSpPr>
+        <p:spPr>
+          <a:xfrm>
+            <a:off x="3259836" y="3374136"/>
+            <a:ext cx="164592" cy="201168"/>
+          </a:xfrm>
+          <a:prstGeom prst="rightArrow">
+            <a:avLst/>
+          </a:prstGeom>
+          <a:solidFill>
+            <a:srgbClr val="256894"/>
+          </a:solidFill>
+          <a:ln>
+            <a:noFill/>
+          </a:ln>
+        </p:spPr>
+        <p:style>
+          <a:lnRef idx="1">
+            <a:schemeClr val="accent1"/>
+          </a:lnRef>
+          <a:fillRef idx="3">
+            <a:schemeClr val="accent1"/>
+          </a:fillRef>
+          <a:effectRef idx="2">
+            <a:schemeClr val="accent1"/>
+          </a:effectRef>
+          <a:fontRef idx="minor">
+            <a:schemeClr val="lt1"/>
+          </a:fontRef>
+        </p:style>
+        <p:txBody>
+          <a:bodyPr rtlCol="0" anchor="ctr"/>
+          <a:lstStyle/>
+          <a:p>
+            <a:pPr algn="ctr"/>
+          </a:p>
+        </p:txBody>
+      </p:sp>
+      <p:sp>
+        <p:nvSpPr>
+          <p:cNvPr id="10" name="Rounded Rectangle 9"/>
+          <p:cNvSpPr/>
+          <p:nvPr/>
+        </p:nvSpPr>
+        <p:spPr>
+          <a:xfrm>
+            <a:off x="3483863" y="2779776"/>
+            <a:ext cx="2468880" cy="1399032"/>
+          </a:xfrm>
+          <a:prstGeom prst="roundRect">
+            <a:avLst/>
+          </a:prstGeom>
+          <a:solidFill>
+            <a:srgbClr val="E5F2F1"/>
+          </a:solidFill>
+          <a:ln>
+            <a:noFill/>
+          </a:ln>
+        </p:spPr>
+        <p:style>
+          <a:lnRef idx="1">
+            <a:schemeClr val="accent1"/>
+          </a:lnRef>
+          <a:fillRef idx="3">
+            <a:schemeClr val="accent1"/>
+          </a:fillRef>
+          <a:effectRef idx="2">
+            <a:schemeClr val="accent1"/>
+          </a:effectRef>
+          <a:fontRef idx="minor">
+            <a:schemeClr val="lt1"/>
+          </a:fontRef>
+        </p:style>
+        <p:txBody>
+          <a:bodyPr rtlCol="0" anchor="ctr"/>
+          <a:lstStyle/>
+          <a:p>
+            <a:pPr algn="ctr"/>
+          </a:p>
+        </p:txBody>
+      </p:sp>
+      <p:sp>
+        <p:nvSpPr>
+          <p:cNvPr id="11" name="TextBox 10"/>
+          <p:cNvSpPr txBox="1"/>
+          <p:nvPr/>
+        </p:nvSpPr>
+        <p:spPr>
+          <a:xfrm>
+            <a:off x="3547871" y="2907792"/>
+            <a:ext cx="2340864" cy="393192"/>
+          </a:xfrm>
+          <a:prstGeom prst="rect">
+            <a:avLst/>
+          </a:prstGeom>
+          <a:noFill/>
+        </p:spPr>
+        <p:txBody>
+          <a:bodyPr wrap="square" lIns="32004" rIns="32004" tIns="4572" bIns="4572" anchor="ctr">
+            <a:spAutoFit/>
+          </a:bodyPr>
+          <a:lstStyle/>
+          <a:p>
+            <a:pPr algn="ctr">
+              <a:lnSpc>
+                <a:spcPct val="104000"/>
+              </a:lnSpc>
+              <a:spcBef>
+                <a:spcPts val="0"/>
+              </a:spcBef>
+              <a:spcAft>
+                <a:spcPts val="0"/>
+              </a:spcAft>
+            </a:pPr>
+            <a:r>
+              <a:rPr sz="2300" b="1">
+                <a:solidFill>
+                  <a:srgbClr val="147E84"/>
+                </a:solidFill>
+                <a:latin typeface="Noto Sans CJK SC"/>
+                <a:ea typeface="Noto Sans CJK SC"/>
+              </a:rPr>
+              <a:t>综合三种信号</a:t>
+            </a:r>
+          </a:p>
+        </p:txBody>
+      </p:sp>
+      <p:sp>
+        <p:nvSpPr>
+          <p:cNvPr id="12" name="TextBox 11"/>
+          <p:cNvSpPr txBox="1"/>
+          <p:nvPr/>
+        </p:nvSpPr>
+        <p:spPr>
+          <a:xfrm>
+            <a:off x="3547871" y="3392424"/>
+            <a:ext cx="2340864" cy="630936"/>
+          </a:xfrm>
+          <a:prstGeom prst="rect">
+            <a:avLst/>
+          </a:prstGeom>
+          <a:noFill/>
+        </p:spPr>
+        <p:txBody>
+          <a:bodyPr wrap="square" lIns="32004" rIns="32004" tIns="4572" bIns="4572" anchor="ctr">
+            <a:spAutoFit/>
+          </a:bodyPr>
+          <a:lstStyle/>
+          <a:p>
+            <a:pPr algn="ctr">
+              <a:lnSpc>
+                <a:spcPct val="104000"/>
+              </a:lnSpc>
+              <a:spcBef>
+                <a:spcPts val="0"/>
+              </a:spcBef>
+              <a:spcAft>
+                <a:spcPts val="0"/>
+              </a:spcAft>
+            </a:pPr>
+            <a:r>
+              <a:rPr sz="2100" b="0">
+                <a:solidFill>
+                  <a:srgbClr val="243E50"/>
+                </a:solidFill>
+                <a:latin typeface="Noto Sans CJK SC"/>
+                <a:ea typeface="Noto Sans CJK SC"/>
+              </a:rPr>
+              <a:t>可靠数据多参考</a:t>
+            </a:r>
+          </a:p>
+          <a:p>
+            <a:pPr algn="ctr">
+              <a:lnSpc>
+                <a:spcPct val="104000"/>
+              </a:lnSpc>
+              <a:spcBef>
+                <a:spcPts val="0"/>
+              </a:spcBef>
+              <a:spcAft>
+                <a:spcPts val="0"/>
+              </a:spcAft>
+            </a:pPr>
+            <a:r>
+              <a:rPr sz="2100" b="0">
+                <a:solidFill>
+                  <a:srgbClr val="243E50"/>
+                </a:solidFill>
+                <a:latin typeface="Noto Sans CJK SC"/>
+                <a:ea typeface="Noto Sans CJK SC"/>
+              </a:rPr>
+              <a:t>低质量数据少参考</a:t>
+            </a:r>
+          </a:p>
+        </p:txBody>
+      </p:sp>
+      <p:sp>
+        <p:nvSpPr>
+          <p:cNvPr id="13" name="Right Arrow 12"/>
+          <p:cNvSpPr/>
+          <p:nvPr/>
+        </p:nvSpPr>
+        <p:spPr>
+          <a:xfrm>
+            <a:off x="6012180" y="3374136"/>
+            <a:ext cx="164592" cy="201168"/>
+          </a:xfrm>
+          <a:prstGeom prst="rightArrow">
+            <a:avLst/>
+          </a:prstGeom>
+          <a:solidFill>
+            <a:srgbClr val="256894"/>
+          </a:solidFill>
+          <a:ln>
+            <a:noFill/>
+          </a:ln>
+        </p:spPr>
+        <p:style>
+          <a:lnRef idx="1">
+            <a:schemeClr val="accent1"/>
+          </a:lnRef>
+          <a:fillRef idx="3">
+            <a:schemeClr val="accent1"/>
+          </a:fillRef>
+          <a:effectRef idx="2">
+            <a:schemeClr val="accent1"/>
+          </a:effectRef>
+          <a:fontRef idx="minor">
+            <a:schemeClr val="lt1"/>
+          </a:fontRef>
+        </p:style>
+        <p:txBody>
+          <a:bodyPr rtlCol="0" anchor="ctr"/>
+          <a:lstStyle/>
+          <a:p>
+            <a:pPr algn="ctr"/>
+          </a:p>
+        </p:txBody>
+      </p:sp>
+      <p:sp>
+        <p:nvSpPr>
+          <p:cNvPr id="14" name="Rounded Rectangle 13"/>
+          <p:cNvSpPr/>
+          <p:nvPr/>
+        </p:nvSpPr>
+        <p:spPr>
+          <a:xfrm>
+            <a:off x="6236207" y="2779776"/>
+            <a:ext cx="2468880" cy="1399032"/>
+          </a:xfrm>
+          <a:prstGeom prst="roundRect">
+            <a:avLst/>
+          </a:prstGeom>
+          <a:solidFill>
+            <a:srgbClr val="E5F2F1"/>
+          </a:solidFill>
+          <a:ln>
+            <a:noFill/>
+          </a:ln>
+        </p:spPr>
+        <p:style>
+          <a:lnRef idx="1">
+            <a:schemeClr val="accent1"/>
+          </a:lnRef>
+          <a:fillRef idx="3">
+            <a:schemeClr val="accent1"/>
+          </a:fillRef>
+          <a:effectRef idx="2">
+            <a:schemeClr val="accent1"/>
+          </a:effectRef>
+          <a:fontRef idx="minor">
+            <a:schemeClr val="lt1"/>
+          </a:fontRef>
+        </p:style>
+        <p:txBody>
+          <a:bodyPr rtlCol="0" anchor="ctr"/>
+          <a:lstStyle/>
+          <a:p>
+            <a:pPr algn="ctr"/>
+          </a:p>
+        </p:txBody>
+      </p:sp>
+      <p:sp>
+        <p:nvSpPr>
+          <p:cNvPr id="15" name="TextBox 14"/>
+          <p:cNvSpPr txBox="1"/>
+          <p:nvPr/>
+        </p:nvSpPr>
+        <p:spPr>
+          <a:xfrm>
+            <a:off x="6300216" y="2907792"/>
+            <a:ext cx="2340864" cy="393192"/>
+          </a:xfrm>
+          <a:prstGeom prst="rect">
+            <a:avLst/>
+          </a:prstGeom>
+          <a:noFill/>
+        </p:spPr>
+        <p:txBody>
+          <a:bodyPr wrap="square" lIns="32004" rIns="32004" tIns="4572" bIns="4572" anchor="ctr">
+            <a:spAutoFit/>
+          </a:bodyPr>
+          <a:lstStyle/>
+          <a:p>
+            <a:pPr algn="ctr">
+              <a:lnSpc>
+                <a:spcPct val="104000"/>
+              </a:lnSpc>
+              <a:spcBef>
+                <a:spcPts val="0"/>
+              </a:spcBef>
+              <a:spcAft>
+                <a:spcPts val="0"/>
+              </a:spcAft>
+            </a:pPr>
+            <a:r>
+              <a:rPr sz="2300" b="1">
+                <a:solidFill>
+                  <a:srgbClr val="147E84"/>
+                </a:solidFill>
+                <a:latin typeface="Noto Sans CJK SC"/>
+                <a:ea typeface="Noto Sans CJK SC"/>
+              </a:rPr>
+              <a:t>观察连续变化</a:t>
+            </a:r>
+          </a:p>
+        </p:txBody>
+      </p:sp>
+      <p:sp>
+        <p:nvSpPr>
+          <p:cNvPr id="16" name="TextBox 15"/>
+          <p:cNvSpPr txBox="1"/>
+          <p:nvPr/>
+        </p:nvSpPr>
+        <p:spPr>
+          <a:xfrm>
+            <a:off x="6300216" y="3392424"/>
+            <a:ext cx="2340864" cy="630936"/>
+          </a:xfrm>
+          <a:prstGeom prst="rect">
+            <a:avLst/>
+          </a:prstGeom>
+          <a:noFill/>
+        </p:spPr>
+        <p:txBody>
+          <a:bodyPr wrap="square" lIns="32004" rIns="32004" tIns="4572" bIns="4572" anchor="ctr">
+            <a:spAutoFit/>
+          </a:bodyPr>
+          <a:lstStyle/>
+          <a:p>
+            <a:pPr algn="ctr">
+              <a:lnSpc>
+                <a:spcPct val="104000"/>
+              </a:lnSpc>
+              <a:spcBef>
+                <a:spcPts val="0"/>
+              </a:spcBef>
+              <a:spcAft>
+                <a:spcPts val="0"/>
+              </a:spcAft>
+            </a:pPr>
+            <a:r>
+              <a:rPr sz="2100" b="0">
+                <a:solidFill>
+                  <a:srgbClr val="243E50"/>
+                </a:solidFill>
+                <a:latin typeface="Noto Sans CJK SC"/>
+                <a:ea typeface="Noto Sans CJK SC"/>
+              </a:rPr>
+              <a:t>联系前后测量</a:t>
+            </a:r>
+          </a:p>
+          <a:p>
+            <a:pPr algn="ctr">
+              <a:lnSpc>
+                <a:spcPct val="104000"/>
+              </a:lnSpc>
+              <a:spcBef>
+                <a:spcPts val="0"/>
+              </a:spcBef>
+              <a:spcAft>
+                <a:spcPts val="0"/>
+              </a:spcAft>
+            </a:pPr>
+            <a:r>
+              <a:rPr sz="2100" b="0">
+                <a:solidFill>
+                  <a:srgbClr val="243E50"/>
+                </a:solidFill>
+                <a:latin typeface="Noto Sans CJK SC"/>
+                <a:ea typeface="Noto Sans CJK SC"/>
+              </a:rPr>
+              <a:t>观察变化趋势</a:t>
+            </a:r>
+          </a:p>
+        </p:txBody>
+      </p:sp>
+      <p:sp>
+        <p:nvSpPr>
+          <p:cNvPr id="17" name="Right Arrow 16"/>
+          <p:cNvSpPr/>
+          <p:nvPr/>
+        </p:nvSpPr>
+        <p:spPr>
+          <a:xfrm>
+            <a:off x="8764524" y="3374136"/>
+            <a:ext cx="164592" cy="201168"/>
+          </a:xfrm>
+          <a:prstGeom prst="rightArrow">
+            <a:avLst/>
+          </a:prstGeom>
+          <a:solidFill>
+            <a:srgbClr val="256894"/>
+          </a:solidFill>
+          <a:ln>
+            <a:noFill/>
+          </a:ln>
+        </p:spPr>
+        <p:style>
+          <a:lnRef idx="1">
+            <a:schemeClr val="accent1"/>
+          </a:lnRef>
+          <a:fillRef idx="3">
+            <a:schemeClr val="accent1"/>
+          </a:fillRef>
+          <a:effectRef idx="2">
+            <a:schemeClr val="accent1"/>
+          </a:effectRef>
+          <a:fontRef idx="minor">
+            <a:schemeClr val="lt1"/>
+          </a:fontRef>
+        </p:style>
+        <p:txBody>
+          <a:bodyPr rtlCol="0" anchor="ctr"/>
+          <a:lstStyle/>
+          <a:p>
+            <a:pPr algn="ctr"/>
+          </a:p>
+        </p:txBody>
+      </p:sp>
+      <p:sp>
+        <p:nvSpPr>
+          <p:cNvPr id="18" name="Rounded Rectangle 17"/>
+          <p:cNvSpPr/>
+          <p:nvPr/>
+        </p:nvSpPr>
+        <p:spPr>
+          <a:xfrm>
+            <a:off x="8988552" y="2779776"/>
+            <a:ext cx="2468880" cy="1399032"/>
+          </a:xfrm>
+          <a:prstGeom prst="roundRect">
+            <a:avLst/>
+          </a:prstGeom>
+          <a:solidFill>
+            <a:srgbClr val="E5F2F1"/>
+          </a:solidFill>
+          <a:ln>
+            <a:noFill/>
+          </a:ln>
+        </p:spPr>
+        <p:style>
+          <a:lnRef idx="1">
+            <a:schemeClr val="accent1"/>
+          </a:lnRef>
+          <a:fillRef idx="3">
+            <a:schemeClr val="accent1"/>
+          </a:fillRef>
+          <a:effectRef idx="2">
+            <a:schemeClr val="accent1"/>
+          </a:effectRef>
+          <a:fontRef idx="minor">
+            <a:schemeClr val="lt1"/>
+          </a:fontRef>
+        </p:style>
+        <p:txBody>
+          <a:bodyPr rtlCol="0" anchor="ctr"/>
+          <a:lstStyle/>
+          <a:p>
+            <a:pPr algn="ctr"/>
+          </a:p>
+        </p:txBody>
+      </p:sp>
+      <p:sp>
+        <p:nvSpPr>
+          <p:cNvPr id="19" name="TextBox 18"/>
+          <p:cNvSpPr txBox="1"/>
+          <p:nvPr/>
+        </p:nvSpPr>
+        <p:spPr>
+          <a:xfrm>
+            <a:off x="9052560" y="2907792"/>
+            <a:ext cx="2340864" cy="393192"/>
+          </a:xfrm>
+          <a:prstGeom prst="rect">
+            <a:avLst/>
+          </a:prstGeom>
+          <a:noFill/>
+        </p:spPr>
+        <p:txBody>
+          <a:bodyPr wrap="square" lIns="32004" rIns="32004" tIns="4572" bIns="4572" anchor="ctr">
+            <a:spAutoFit/>
+          </a:bodyPr>
+          <a:lstStyle/>
+          <a:p>
+            <a:pPr algn="ctr">
+              <a:lnSpc>
+                <a:spcPct val="104000"/>
+              </a:lnSpc>
+              <a:spcBef>
+                <a:spcPts val="0"/>
+              </a:spcBef>
+              <a:spcAft>
+                <a:spcPts val="0"/>
+              </a:spcAft>
+            </a:pPr>
+            <a:r>
+              <a:rPr sz="2300" b="1">
+                <a:solidFill>
+                  <a:srgbClr val="147E84"/>
+                </a:solidFill>
+                <a:latin typeface="Noto Sans CJK SC"/>
+                <a:ea typeface="Noto Sans CJK SC"/>
+              </a:rPr>
+              <a:t>输出仿真结果</a:t>
+            </a:r>
+          </a:p>
+        </p:txBody>
+      </p:sp>
+      <p:sp>
+        <p:nvSpPr>
+          <p:cNvPr id="20" name="TextBox 19"/>
+          <p:cNvSpPr txBox="1"/>
+          <p:nvPr/>
+        </p:nvSpPr>
+        <p:spPr>
+          <a:xfrm>
+            <a:off x="9052560" y="3392424"/>
+            <a:ext cx="2340864" cy="630936"/>
+          </a:xfrm>
+          <a:prstGeom prst="rect">
+            <a:avLst/>
+          </a:prstGeom>
+          <a:noFill/>
+        </p:spPr>
+        <p:txBody>
+          <a:bodyPr wrap="square" lIns="32004" rIns="32004" tIns="4572" bIns="4572" anchor="ctr">
+            <a:spAutoFit/>
+          </a:bodyPr>
+          <a:lstStyle/>
+          <a:p>
+            <a:pPr algn="ctr">
+              <a:lnSpc>
+                <a:spcPct val="104000"/>
+              </a:lnSpc>
+              <a:spcBef>
+                <a:spcPts val="0"/>
+              </a:spcBef>
+              <a:spcAft>
+                <a:spcPts val="0"/>
+              </a:spcAft>
+            </a:pPr>
+            <a:r>
+              <a:rPr sz="2100" b="0">
+                <a:solidFill>
+                  <a:srgbClr val="243E50"/>
+                </a:solidFill>
+                <a:latin typeface="Noto Sans CJK SC"/>
+                <a:ea typeface="Noto Sans CJK SC"/>
+              </a:rPr>
+              <a:t>状态与健康程度</a:t>
+            </a:r>
+          </a:p>
+          <a:p>
+            <a:pPr algn="ctr">
+              <a:lnSpc>
+                <a:spcPct val="104000"/>
+              </a:lnSpc>
+              <a:spcBef>
+                <a:spcPts val="0"/>
+              </a:spcBef>
+              <a:spcAft>
+                <a:spcPts val="0"/>
+              </a:spcAft>
+            </a:pPr>
+            <a:r>
+              <a:rPr sz="2100" b="0">
+                <a:solidFill>
+                  <a:srgbClr val="243E50"/>
+                </a:solidFill>
+                <a:latin typeface="Noto Sans CJK SC"/>
+                <a:ea typeface="Noto Sans CJK SC"/>
+              </a:rPr>
+              <a:t>仿真寿命范围</a:t>
+            </a:r>
+          </a:p>
+        </p:txBody>
+      </p:sp>
+      <p:sp>
+        <p:nvSpPr>
+          <p:cNvPr id="21" name="Rounded Rectangle 20"/>
+          <p:cNvSpPr/>
+          <p:nvPr/>
+        </p:nvSpPr>
+        <p:spPr>
+          <a:xfrm>
+            <a:off x="731520" y="4553712"/>
+            <a:ext cx="10725912" cy="905256"/>
           </a:xfrm>
           <a:prstGeom prst="roundRect">
             <a:avLst/>
@@ -3792,841 +4594,14 @@
       </p:sp>
       <p:sp>
         <p:nvSpPr>
-          <p:cNvPr id="7" name="TextBox 6"/>
+          <p:cNvPr id="22" name="TextBox 21"/>
           <p:cNvSpPr txBox="1"/>
           <p:nvPr/>
         </p:nvSpPr>
         <p:spPr>
           <a:xfrm>
-            <a:off x="781812" y="2542032"/>
-            <a:ext cx="1865376" cy="356616"/>
-          </a:xfrm>
-          <a:prstGeom prst="rect">
-            <a:avLst/>
-          </a:prstGeom>
-          <a:noFill/>
-        </p:spPr>
-        <p:txBody>
-          <a:bodyPr wrap="square" lIns="32004" rIns="32004" tIns="4572" bIns="4572" anchor="ctr">
-            <a:spAutoFit/>
-          </a:bodyPr>
-          <a:lstStyle/>
-          <a:p>
-            <a:pPr algn="ctr">
-              <a:lnSpc>
-                <a:spcPct val="104000"/>
-              </a:lnSpc>
-              <a:spcBef>
-                <a:spcPts val="0"/>
-              </a:spcBef>
-              <a:spcAft>
-                <a:spcPts val="0"/>
-              </a:spcAft>
-            </a:pPr>
-            <a:r>
-              <a:rPr sz="2100" b="1">
-                <a:solidFill>
-                  <a:srgbClr val="256894"/>
-                </a:solidFill>
-                <a:latin typeface="Noto Sans CJK SC"/>
-                <a:ea typeface="Noto Sans CJK SC"/>
-              </a:rPr>
-              <a:t>工况校正</a:t>
-            </a:r>
-          </a:p>
-        </p:txBody>
-      </p:sp>
-      <p:sp>
-        <p:nvSpPr>
-          <p:cNvPr id="8" name="TextBox 7"/>
-          <p:cNvSpPr txBox="1"/>
-          <p:nvPr/>
-        </p:nvSpPr>
-        <p:spPr>
-          <a:xfrm>
-            <a:off x="781812" y="2916936"/>
-            <a:ext cx="1865376" cy="566928"/>
-          </a:xfrm>
-          <a:prstGeom prst="rect">
-            <a:avLst/>
-          </a:prstGeom>
-          <a:noFill/>
-        </p:spPr>
-        <p:txBody>
-          <a:bodyPr wrap="square" lIns="32004" rIns="32004" tIns="4572" bIns="4572" anchor="ctr">
-            <a:spAutoFit/>
-          </a:bodyPr>
-          <a:lstStyle/>
-          <a:p>
-            <a:pPr algn="ctr">
-              <a:lnSpc>
-                <a:spcPct val="104000"/>
-              </a:lnSpc>
-              <a:spcBef>
-                <a:spcPts val="0"/>
-              </a:spcBef>
-              <a:spcAft>
-                <a:spcPts val="0"/>
-              </a:spcAft>
-            </a:pPr>
-            <a:r>
-              <a:rPr sz="2100" b="0">
-                <a:solidFill>
-                  <a:srgbClr val="243E50"/>
-                </a:solidFill>
-                <a:latin typeface="Noto Sans CJK SC"/>
-                <a:ea typeface="Noto Sans CJK SC"/>
-              </a:rPr>
-              <a:t>减弱工况干扰</a:t>
-            </a:r>
-          </a:p>
-        </p:txBody>
-      </p:sp>
-      <p:sp>
-        <p:nvSpPr>
-          <p:cNvPr id="9" name="Right Arrow 8"/>
-          <p:cNvSpPr/>
-          <p:nvPr/>
-        </p:nvSpPr>
-        <p:spPr>
-          <a:xfrm>
-            <a:off x="2738628" y="2916936"/>
-            <a:ext cx="137160" cy="173736"/>
-          </a:xfrm>
-          <a:prstGeom prst="rightArrow">
-            <a:avLst/>
-          </a:prstGeom>
-          <a:solidFill>
-            <a:srgbClr val="256894"/>
-          </a:solidFill>
-          <a:ln>
-            <a:noFill/>
-          </a:ln>
-        </p:spPr>
-        <p:style>
-          <a:lnRef idx="1">
-            <a:schemeClr val="accent1"/>
-          </a:lnRef>
-          <a:fillRef idx="3">
-            <a:schemeClr val="accent1"/>
-          </a:fillRef>
-          <a:effectRef idx="2">
-            <a:schemeClr val="accent1"/>
-          </a:effectRef>
-          <a:fontRef idx="minor">
-            <a:schemeClr val="lt1"/>
-          </a:fontRef>
-        </p:style>
-        <p:txBody>
-          <a:bodyPr rtlCol="0" anchor="ctr"/>
-          <a:lstStyle/>
-          <a:p>
-            <a:pPr algn="ctr"/>
-          </a:p>
-        </p:txBody>
-      </p:sp>
-      <p:sp>
-        <p:nvSpPr>
-          <p:cNvPr id="10" name="Rounded Rectangle 9"/>
-          <p:cNvSpPr/>
-          <p:nvPr/>
-        </p:nvSpPr>
-        <p:spPr>
-          <a:xfrm>
-            <a:off x="2921508" y="2487168"/>
-            <a:ext cx="1965960" cy="1051560"/>
-          </a:xfrm>
-          <a:prstGeom prst="roundRect">
-            <a:avLst/>
-          </a:prstGeom>
-          <a:solidFill>
-            <a:srgbClr val="EAF2F8"/>
-          </a:solidFill>
-          <a:ln>
-            <a:noFill/>
-          </a:ln>
-        </p:spPr>
-        <p:style>
-          <a:lnRef idx="1">
-            <a:schemeClr val="accent1"/>
-          </a:lnRef>
-          <a:fillRef idx="3">
-            <a:schemeClr val="accent1"/>
-          </a:fillRef>
-          <a:effectRef idx="2">
-            <a:schemeClr val="accent1"/>
-          </a:effectRef>
-          <a:fontRef idx="minor">
-            <a:schemeClr val="lt1"/>
-          </a:fontRef>
-        </p:style>
-        <p:txBody>
-          <a:bodyPr rtlCol="0" anchor="ctr"/>
-          <a:lstStyle/>
-          <a:p>
-            <a:pPr algn="ctr"/>
-          </a:p>
-        </p:txBody>
-      </p:sp>
-      <p:sp>
-        <p:nvSpPr>
-          <p:cNvPr id="11" name="TextBox 10"/>
-          <p:cNvSpPr txBox="1"/>
-          <p:nvPr/>
-        </p:nvSpPr>
-        <p:spPr>
-          <a:xfrm>
-            <a:off x="2971800" y="2542032"/>
-            <a:ext cx="1865376" cy="356616"/>
-          </a:xfrm>
-          <a:prstGeom prst="rect">
-            <a:avLst/>
-          </a:prstGeom>
-          <a:noFill/>
-        </p:spPr>
-        <p:txBody>
-          <a:bodyPr wrap="square" lIns="32004" rIns="32004" tIns="4572" bIns="4572" anchor="ctr">
-            <a:spAutoFit/>
-          </a:bodyPr>
-          <a:lstStyle/>
-          <a:p>
-            <a:pPr algn="ctr">
-              <a:lnSpc>
-                <a:spcPct val="104000"/>
-              </a:lnSpc>
-              <a:spcBef>
-                <a:spcPts val="0"/>
-              </a:spcBef>
-              <a:spcAft>
-                <a:spcPts val="0"/>
-              </a:spcAft>
-            </a:pPr>
-            <a:r>
-              <a:rPr sz="2100" b="1">
-                <a:solidFill>
-                  <a:srgbClr val="256894"/>
-                </a:solidFill>
-                <a:latin typeface="Noto Sans CJK SC"/>
-                <a:ea typeface="Noto Sans CJK SC"/>
-              </a:rPr>
-              <a:t>质量门控融合</a:t>
-            </a:r>
-          </a:p>
-        </p:txBody>
-      </p:sp>
-      <p:sp>
-        <p:nvSpPr>
-          <p:cNvPr id="12" name="TextBox 11"/>
-          <p:cNvSpPr txBox="1"/>
-          <p:nvPr/>
-        </p:nvSpPr>
-        <p:spPr>
-          <a:xfrm>
-            <a:off x="2971800" y="2916936"/>
-            <a:ext cx="1865376" cy="566928"/>
-          </a:xfrm>
-          <a:prstGeom prst="rect">
-            <a:avLst/>
-          </a:prstGeom>
-          <a:noFill/>
-        </p:spPr>
-        <p:txBody>
-          <a:bodyPr wrap="square" lIns="32004" rIns="32004" tIns="4572" bIns="4572" anchor="ctr">
-            <a:spAutoFit/>
-          </a:bodyPr>
-          <a:lstStyle/>
-          <a:p>
-            <a:pPr algn="ctr">
-              <a:lnSpc>
-                <a:spcPct val="104000"/>
-              </a:lnSpc>
-              <a:spcBef>
-                <a:spcPts val="0"/>
-              </a:spcBef>
-              <a:spcAft>
-                <a:spcPts val="0"/>
-              </a:spcAft>
-            </a:pPr>
-            <a:r>
-              <a:rPr sz="2100" b="0">
-                <a:solidFill>
-                  <a:srgbClr val="243E50"/>
-                </a:solidFill>
-                <a:latin typeface="Noto Sans CJK SC"/>
-                <a:ea typeface="Noto Sans CJK SC"/>
-              </a:rPr>
-              <a:t>控制通道贡献</a:t>
-            </a:r>
-          </a:p>
-        </p:txBody>
-      </p:sp>
-      <p:sp>
-        <p:nvSpPr>
-          <p:cNvPr id="13" name="Right Arrow 12"/>
-          <p:cNvSpPr/>
-          <p:nvPr/>
-        </p:nvSpPr>
-        <p:spPr>
-          <a:xfrm>
-            <a:off x="4928616" y="2916936"/>
-            <a:ext cx="137160" cy="173736"/>
-          </a:xfrm>
-          <a:prstGeom prst="rightArrow">
-            <a:avLst/>
-          </a:prstGeom>
-          <a:solidFill>
-            <a:srgbClr val="256894"/>
-          </a:solidFill>
-          <a:ln>
-            <a:noFill/>
-          </a:ln>
-        </p:spPr>
-        <p:style>
-          <a:lnRef idx="1">
-            <a:schemeClr val="accent1"/>
-          </a:lnRef>
-          <a:fillRef idx="3">
-            <a:schemeClr val="accent1"/>
-          </a:fillRef>
-          <a:effectRef idx="2">
-            <a:schemeClr val="accent1"/>
-          </a:effectRef>
-          <a:fontRef idx="minor">
-            <a:schemeClr val="lt1"/>
-          </a:fontRef>
-        </p:style>
-        <p:txBody>
-          <a:bodyPr rtlCol="0" anchor="ctr"/>
-          <a:lstStyle/>
-          <a:p>
-            <a:pPr algn="ctr"/>
-          </a:p>
-        </p:txBody>
-      </p:sp>
-      <p:sp>
-        <p:nvSpPr>
-          <p:cNvPr id="14" name="Rounded Rectangle 13"/>
-          <p:cNvSpPr/>
-          <p:nvPr/>
-        </p:nvSpPr>
-        <p:spPr>
-          <a:xfrm>
-            <a:off x="5111496" y="2487168"/>
-            <a:ext cx="1965960" cy="1051560"/>
-          </a:xfrm>
-          <a:prstGeom prst="roundRect">
-            <a:avLst/>
-          </a:prstGeom>
-          <a:solidFill>
-            <a:srgbClr val="EAF2F8"/>
-          </a:solidFill>
-          <a:ln>
-            <a:noFill/>
-          </a:ln>
-        </p:spPr>
-        <p:style>
-          <a:lnRef idx="1">
-            <a:schemeClr val="accent1"/>
-          </a:lnRef>
-          <a:fillRef idx="3">
-            <a:schemeClr val="accent1"/>
-          </a:fillRef>
-          <a:effectRef idx="2">
-            <a:schemeClr val="accent1"/>
-          </a:effectRef>
-          <a:fontRef idx="minor">
-            <a:schemeClr val="lt1"/>
-          </a:fontRef>
-        </p:style>
-        <p:txBody>
-          <a:bodyPr rtlCol="0" anchor="ctr"/>
-          <a:lstStyle/>
-          <a:p>
-            <a:pPr algn="ctr"/>
-          </a:p>
-        </p:txBody>
-      </p:sp>
-      <p:sp>
-        <p:nvSpPr>
-          <p:cNvPr id="15" name="TextBox 14"/>
-          <p:cNvSpPr txBox="1"/>
-          <p:nvPr/>
-        </p:nvSpPr>
-        <p:spPr>
-          <a:xfrm>
-            <a:off x="5161788" y="2542032"/>
-            <a:ext cx="1865376" cy="356616"/>
-          </a:xfrm>
-          <a:prstGeom prst="rect">
-            <a:avLst/>
-          </a:prstGeom>
-          <a:noFill/>
-        </p:spPr>
-        <p:txBody>
-          <a:bodyPr wrap="square" lIns="32004" rIns="32004" tIns="4572" bIns="4572" anchor="ctr">
-            <a:spAutoFit/>
-          </a:bodyPr>
-          <a:lstStyle/>
-          <a:p>
-            <a:pPr algn="ctr">
-              <a:lnSpc>
-                <a:spcPct val="104000"/>
-              </a:lnSpc>
-              <a:spcBef>
-                <a:spcPts val="0"/>
-              </a:spcBef>
-              <a:spcAft>
-                <a:spcPts val="0"/>
-              </a:spcAft>
-            </a:pPr>
-            <a:r>
-              <a:rPr sz="2100" b="1">
-                <a:solidFill>
-                  <a:srgbClr val="256894"/>
-                </a:solidFill>
-                <a:latin typeface="Noto Sans CJK SC"/>
-                <a:ea typeface="Noto Sans CJK SC"/>
-              </a:rPr>
-              <a:t>Transformer</a:t>
-            </a:r>
-          </a:p>
-        </p:txBody>
-      </p:sp>
-      <p:sp>
-        <p:nvSpPr>
-          <p:cNvPr id="16" name="TextBox 15"/>
-          <p:cNvSpPr txBox="1"/>
-          <p:nvPr/>
-        </p:nvSpPr>
-        <p:spPr>
-          <a:xfrm>
-            <a:off x="5161788" y="2916936"/>
-            <a:ext cx="1865376" cy="566928"/>
-          </a:xfrm>
-          <a:prstGeom prst="rect">
-            <a:avLst/>
-          </a:prstGeom>
-          <a:noFill/>
-        </p:spPr>
-        <p:txBody>
-          <a:bodyPr wrap="square" lIns="32004" rIns="32004" tIns="4572" bIns="4572" anchor="ctr">
-            <a:spAutoFit/>
-          </a:bodyPr>
-          <a:lstStyle/>
-          <a:p>
-            <a:pPr algn="ctr">
-              <a:lnSpc>
-                <a:spcPct val="104000"/>
-              </a:lnSpc>
-              <a:spcBef>
-                <a:spcPts val="0"/>
-              </a:spcBef>
-              <a:spcAft>
-                <a:spcPts val="0"/>
-              </a:spcAft>
-            </a:pPr>
-            <a:r>
-              <a:rPr sz="2100" b="0">
-                <a:solidFill>
-                  <a:srgbClr val="243E50"/>
-                </a:solidFill>
-                <a:latin typeface="Noto Sans CJK SC"/>
-                <a:ea typeface="Noto Sans CJK SC"/>
-              </a:rPr>
-              <a:t>关联窗口信息</a:t>
-            </a:r>
-          </a:p>
-        </p:txBody>
-      </p:sp>
-      <p:sp>
-        <p:nvSpPr>
-          <p:cNvPr id="17" name="Right Arrow 16"/>
-          <p:cNvSpPr/>
-          <p:nvPr/>
-        </p:nvSpPr>
-        <p:spPr>
-          <a:xfrm>
-            <a:off x="7118604" y="2916936"/>
-            <a:ext cx="137160" cy="173736"/>
-          </a:xfrm>
-          <a:prstGeom prst="rightArrow">
-            <a:avLst/>
-          </a:prstGeom>
-          <a:solidFill>
-            <a:srgbClr val="256894"/>
-          </a:solidFill>
-          <a:ln>
-            <a:noFill/>
-          </a:ln>
-        </p:spPr>
-        <p:style>
-          <a:lnRef idx="1">
-            <a:schemeClr val="accent1"/>
-          </a:lnRef>
-          <a:fillRef idx="3">
-            <a:schemeClr val="accent1"/>
-          </a:fillRef>
-          <a:effectRef idx="2">
-            <a:schemeClr val="accent1"/>
-          </a:effectRef>
-          <a:fontRef idx="minor">
-            <a:schemeClr val="lt1"/>
-          </a:fontRef>
-        </p:style>
-        <p:txBody>
-          <a:bodyPr rtlCol="0" anchor="ctr"/>
-          <a:lstStyle/>
-          <a:p>
-            <a:pPr algn="ctr"/>
-          </a:p>
-        </p:txBody>
-      </p:sp>
-      <p:sp>
-        <p:nvSpPr>
-          <p:cNvPr id="18" name="Rounded Rectangle 17"/>
-          <p:cNvSpPr/>
-          <p:nvPr/>
-        </p:nvSpPr>
-        <p:spPr>
-          <a:xfrm>
-            <a:off x="7301484" y="2487168"/>
-            <a:ext cx="1965960" cy="1051560"/>
-          </a:xfrm>
-          <a:prstGeom prst="roundRect">
-            <a:avLst/>
-          </a:prstGeom>
-          <a:solidFill>
-            <a:srgbClr val="EAF2F8"/>
-          </a:solidFill>
-          <a:ln>
-            <a:noFill/>
-          </a:ln>
-        </p:spPr>
-        <p:style>
-          <a:lnRef idx="1">
-            <a:schemeClr val="accent1"/>
-          </a:lnRef>
-          <a:fillRef idx="3">
-            <a:schemeClr val="accent1"/>
-          </a:fillRef>
-          <a:effectRef idx="2">
-            <a:schemeClr val="accent1"/>
-          </a:effectRef>
-          <a:fontRef idx="minor">
-            <a:schemeClr val="lt1"/>
-          </a:fontRef>
-        </p:style>
-        <p:txBody>
-          <a:bodyPr rtlCol="0" anchor="ctr"/>
-          <a:lstStyle/>
-          <a:p>
-            <a:pPr algn="ctr"/>
-          </a:p>
-        </p:txBody>
-      </p:sp>
-      <p:sp>
-        <p:nvSpPr>
-          <p:cNvPr id="19" name="TextBox 18"/>
-          <p:cNvSpPr txBox="1"/>
-          <p:nvPr/>
-        </p:nvSpPr>
-        <p:spPr>
-          <a:xfrm>
-            <a:off x="7351776" y="2542032"/>
-            <a:ext cx="1865376" cy="356616"/>
-          </a:xfrm>
-          <a:prstGeom prst="rect">
-            <a:avLst/>
-          </a:prstGeom>
-          <a:noFill/>
-        </p:spPr>
-        <p:txBody>
-          <a:bodyPr wrap="square" lIns="32004" rIns="32004" tIns="4572" bIns="4572" anchor="ctr">
-            <a:spAutoFit/>
-          </a:bodyPr>
-          <a:lstStyle/>
-          <a:p>
-            <a:pPr algn="ctr">
-              <a:lnSpc>
-                <a:spcPct val="104000"/>
-              </a:lnSpc>
-              <a:spcBef>
-                <a:spcPts val="0"/>
-              </a:spcBef>
-              <a:spcAft>
-                <a:spcPts val="0"/>
-              </a:spcAft>
-            </a:pPr>
-            <a:r>
-              <a:rPr sz="2100" b="1">
-                <a:solidFill>
-                  <a:srgbClr val="256894"/>
-                </a:solidFill>
-                <a:latin typeface="Noto Sans CJK SC"/>
-                <a:ea typeface="Noto Sans CJK SC"/>
-              </a:rPr>
-              <a:t>LSTM</a:t>
-            </a:r>
-          </a:p>
-        </p:txBody>
-      </p:sp>
-      <p:sp>
-        <p:nvSpPr>
-          <p:cNvPr id="20" name="TextBox 19"/>
-          <p:cNvSpPr txBox="1"/>
-          <p:nvPr/>
-        </p:nvSpPr>
-        <p:spPr>
-          <a:xfrm>
-            <a:off x="7351776" y="2916936"/>
-            <a:ext cx="1865376" cy="566928"/>
-          </a:xfrm>
-          <a:prstGeom prst="rect">
-            <a:avLst/>
-          </a:prstGeom>
-          <a:noFill/>
-        </p:spPr>
-        <p:txBody>
-          <a:bodyPr wrap="square" lIns="32004" rIns="32004" tIns="4572" bIns="4572" anchor="ctr">
-            <a:spAutoFit/>
-          </a:bodyPr>
-          <a:lstStyle/>
-          <a:p>
-            <a:pPr algn="ctr">
-              <a:lnSpc>
-                <a:spcPct val="104000"/>
-              </a:lnSpc>
-              <a:spcBef>
-                <a:spcPts val="0"/>
-              </a:spcBef>
-              <a:spcAft>
-                <a:spcPts val="0"/>
-              </a:spcAft>
-            </a:pPr>
-            <a:r>
-              <a:rPr sz="2100" b="0">
-                <a:solidFill>
-                  <a:srgbClr val="243E50"/>
-                </a:solidFill>
-                <a:latin typeface="Noto Sans CJK SC"/>
-                <a:ea typeface="Noto Sans CJK SC"/>
-              </a:rPr>
-              <a:t>汇总变化趋势</a:t>
-            </a:r>
-          </a:p>
-        </p:txBody>
-      </p:sp>
-      <p:sp>
-        <p:nvSpPr>
-          <p:cNvPr id="21" name="Right Arrow 20"/>
-          <p:cNvSpPr/>
-          <p:nvPr/>
-        </p:nvSpPr>
-        <p:spPr>
-          <a:xfrm>
-            <a:off x="9308592" y="2916936"/>
-            <a:ext cx="137160" cy="173736"/>
-          </a:xfrm>
-          <a:prstGeom prst="rightArrow">
-            <a:avLst/>
-          </a:prstGeom>
-          <a:solidFill>
-            <a:srgbClr val="256894"/>
-          </a:solidFill>
-          <a:ln>
-            <a:noFill/>
-          </a:ln>
-        </p:spPr>
-        <p:style>
-          <a:lnRef idx="1">
-            <a:schemeClr val="accent1"/>
-          </a:lnRef>
-          <a:fillRef idx="3">
-            <a:schemeClr val="accent1"/>
-          </a:fillRef>
-          <a:effectRef idx="2">
-            <a:schemeClr val="accent1"/>
-          </a:effectRef>
-          <a:fontRef idx="minor">
-            <a:schemeClr val="lt1"/>
-          </a:fontRef>
-        </p:style>
-        <p:txBody>
-          <a:bodyPr rtlCol="0" anchor="ctr"/>
-          <a:lstStyle/>
-          <a:p>
-            <a:pPr algn="ctr"/>
-          </a:p>
-        </p:txBody>
-      </p:sp>
-      <p:sp>
-        <p:nvSpPr>
-          <p:cNvPr id="22" name="Rounded Rectangle 21"/>
-          <p:cNvSpPr/>
-          <p:nvPr/>
-        </p:nvSpPr>
-        <p:spPr>
-          <a:xfrm>
-            <a:off x="9491472" y="2487168"/>
-            <a:ext cx="1965960" cy="1051560"/>
-          </a:xfrm>
-          <a:prstGeom prst="roundRect">
-            <a:avLst/>
-          </a:prstGeom>
-          <a:solidFill>
-            <a:srgbClr val="EAF2F8"/>
-          </a:solidFill>
-          <a:ln>
-            <a:noFill/>
-          </a:ln>
-        </p:spPr>
-        <p:style>
-          <a:lnRef idx="1">
-            <a:schemeClr val="accent1"/>
-          </a:lnRef>
-          <a:fillRef idx="3">
-            <a:schemeClr val="accent1"/>
-          </a:fillRef>
-          <a:effectRef idx="2">
-            <a:schemeClr val="accent1"/>
-          </a:effectRef>
-          <a:fontRef idx="minor">
-            <a:schemeClr val="lt1"/>
-          </a:fontRef>
-        </p:style>
-        <p:txBody>
-          <a:bodyPr rtlCol="0" anchor="ctr"/>
-          <a:lstStyle/>
-          <a:p>
-            <a:pPr algn="ctr"/>
-          </a:p>
-        </p:txBody>
-      </p:sp>
-      <p:sp>
-        <p:nvSpPr>
-          <p:cNvPr id="23" name="TextBox 22"/>
-          <p:cNvSpPr txBox="1"/>
-          <p:nvPr/>
-        </p:nvSpPr>
-        <p:spPr>
-          <a:xfrm>
-            <a:off x="9541764" y="2542032"/>
-            <a:ext cx="1865376" cy="356616"/>
-          </a:xfrm>
-          <a:prstGeom prst="rect">
-            <a:avLst/>
-          </a:prstGeom>
-          <a:noFill/>
-        </p:spPr>
-        <p:txBody>
-          <a:bodyPr wrap="square" lIns="32004" rIns="32004" tIns="4572" bIns="4572" anchor="ctr">
-            <a:spAutoFit/>
-          </a:bodyPr>
-          <a:lstStyle/>
-          <a:p>
-            <a:pPr algn="ctr">
-              <a:lnSpc>
-                <a:spcPct val="104000"/>
-              </a:lnSpc>
-              <a:spcBef>
-                <a:spcPts val="0"/>
-              </a:spcBef>
-              <a:spcAft>
-                <a:spcPts val="0"/>
-              </a:spcAft>
-            </a:pPr>
-            <a:r>
-              <a:rPr sz="2100" b="1">
-                <a:solidFill>
-                  <a:srgbClr val="256894"/>
-                </a:solidFill>
-                <a:latin typeface="Noto Sans CJK SC"/>
-                <a:ea typeface="Noto Sans CJK SC"/>
-              </a:rPr>
-              <a:t>多任务输出</a:t>
-            </a:r>
-          </a:p>
-        </p:txBody>
-      </p:sp>
-      <p:sp>
-        <p:nvSpPr>
-          <p:cNvPr id="24" name="TextBox 23"/>
-          <p:cNvSpPr txBox="1"/>
-          <p:nvPr/>
-        </p:nvSpPr>
-        <p:spPr>
-          <a:xfrm>
-            <a:off x="9541764" y="2916936"/>
-            <a:ext cx="1865376" cy="566928"/>
-          </a:xfrm>
-          <a:prstGeom prst="rect">
-            <a:avLst/>
-          </a:prstGeom>
-          <a:noFill/>
-        </p:spPr>
-        <p:txBody>
-          <a:bodyPr wrap="square" lIns="32004" rIns="32004" tIns="4572" bIns="4572" anchor="ctr">
-            <a:spAutoFit/>
-          </a:bodyPr>
-          <a:lstStyle/>
-          <a:p>
-            <a:pPr algn="ctr">
-              <a:lnSpc>
-                <a:spcPct val="104000"/>
-              </a:lnSpc>
-              <a:spcBef>
-                <a:spcPts val="0"/>
-              </a:spcBef>
-              <a:spcAft>
-                <a:spcPts val="0"/>
-              </a:spcAft>
-            </a:pPr>
-            <a:r>
-              <a:rPr sz="2100" b="0">
-                <a:solidFill>
-                  <a:srgbClr val="243E50"/>
-                </a:solidFill>
-                <a:latin typeface="Noto Sans CJK SC"/>
-                <a:ea typeface="Noto Sans CJK SC"/>
-              </a:rPr>
-              <a:t>状态／健康</a:t>
-            </a:r>
-          </a:p>
-          <a:p>
-            <a:pPr algn="ctr">
-              <a:lnSpc>
-                <a:spcPct val="104000"/>
-              </a:lnSpc>
-              <a:spcBef>
-                <a:spcPts val="0"/>
-              </a:spcBef>
-              <a:spcAft>
-                <a:spcPts val="0"/>
-              </a:spcAft>
-            </a:pPr>
-            <a:r>
-              <a:rPr sz="2100" b="0">
-                <a:solidFill>
-                  <a:srgbClr val="243E50"/>
-                </a:solidFill>
-                <a:latin typeface="Noto Sans CJK SC"/>
-                <a:ea typeface="Noto Sans CJK SC"/>
-              </a:rPr>
-              <a:t>仿真寿命区间</a:t>
-            </a:r>
-          </a:p>
-        </p:txBody>
-      </p:sp>
-      <p:sp>
-        <p:nvSpPr>
-          <p:cNvPr id="25" name="TextBox 24"/>
-          <p:cNvSpPr txBox="1"/>
-          <p:nvPr/>
-        </p:nvSpPr>
-        <p:spPr>
-          <a:xfrm>
-            <a:off x="749808" y="3657600"/>
-            <a:ext cx="10689336" cy="329184"/>
+            <a:off x="923544" y="4663440"/>
+            <a:ext cx="10341864" cy="676656"/>
           </a:xfrm>
           <a:prstGeom prst="rect">
             <a:avLst/>
@@ -4651,39 +4626,16 @@
               </a:spcAft>
             </a:pPr>
             <a:r>
-              <a:rPr sz="2100" b="0">
+              <a:rPr sz="2300" b="0">
                 <a:solidFill>
                   <a:srgbClr val="243E50"/>
                 </a:solidFill>
                 <a:latin typeface="Noto Sans CJK SC"/>
                 <a:ea typeface="Noto Sans CJK SC"/>
               </a:rPr>
-              <a:t>输出接入：网页展示、分级告警、维修工单与复测流程</a:t>
-            </a:r>
-          </a:p>
-        </p:txBody>
-      </p:sp>
-      <p:sp>
-        <p:nvSpPr>
-          <p:cNvPr id="26" name="TextBox 25"/>
-          <p:cNvSpPr txBox="1"/>
-          <p:nvPr/>
-        </p:nvSpPr>
-        <p:spPr>
-          <a:xfrm>
-            <a:off x="731520" y="4178808"/>
-            <a:ext cx="10725912" cy="384048"/>
-          </a:xfrm>
-          <a:prstGeom prst="rect">
-            <a:avLst/>
-          </a:prstGeom>
-          <a:noFill/>
-        </p:spPr>
-        <p:txBody>
-          <a:bodyPr wrap="square" lIns="32004" rIns="32004" tIns="4572" bIns="4572" anchor="ctr">
-            <a:spAutoFit/>
-          </a:bodyPr>
-          <a:lstStyle/>
+              <a:t>例如：负载增加时，振动变大可能是正常变化；</a:t>
+            </a:r>
+          </a:p>
           <a:p>
             <a:pPr algn="l">
               <a:lnSpc>
@@ -4697,763 +4649,28 @@
               </a:spcAft>
             </a:pPr>
             <a:r>
-              <a:rPr sz="2300" b="1">
-                <a:solidFill>
-                  <a:srgbClr val="147E84"/>
-                </a:solidFill>
-                <a:latin typeface="Noto Sans CJK SC"/>
-                <a:ea typeface="Noto Sans CJK SC"/>
-              </a:rPr>
-              <a:t>公开数据预验证：轴承故障部位分类</a:t>
-            </a:r>
-          </a:p>
-        </p:txBody>
-      </p:sp>
-      <p:sp>
-        <p:nvSpPr>
-          <p:cNvPr id="27" name="Rounded Rectangle 26"/>
-          <p:cNvSpPr/>
-          <p:nvPr/>
-        </p:nvSpPr>
-        <p:spPr>
-          <a:xfrm>
-            <a:off x="731520" y="4727448"/>
-            <a:ext cx="2468880" cy="1033271"/>
-          </a:xfrm>
-          <a:prstGeom prst="roundRect">
-            <a:avLst/>
-          </a:prstGeom>
-          <a:solidFill>
-            <a:srgbClr val="E5F2F1"/>
-          </a:solidFill>
-          <a:ln>
-            <a:noFill/>
-          </a:ln>
-        </p:spPr>
-        <p:style>
-          <a:lnRef idx="1">
-            <a:schemeClr val="accent1"/>
-          </a:lnRef>
-          <a:fillRef idx="3">
-            <a:schemeClr val="accent1"/>
-          </a:fillRef>
-          <a:effectRef idx="2">
-            <a:schemeClr val="accent1"/>
-          </a:effectRef>
-          <a:fontRef idx="minor">
-            <a:schemeClr val="lt1"/>
-          </a:fontRef>
-        </p:style>
-        <p:txBody>
-          <a:bodyPr rtlCol="0" anchor="ctr"/>
-          <a:lstStyle/>
-          <a:p>
-            <a:pPr algn="ctr"/>
-          </a:p>
-        </p:txBody>
-      </p:sp>
-      <p:sp>
-        <p:nvSpPr>
-          <p:cNvPr id="28" name="TextBox 27"/>
-          <p:cNvSpPr txBox="1"/>
-          <p:nvPr/>
-        </p:nvSpPr>
-        <p:spPr>
-          <a:xfrm>
-            <a:off x="795528" y="4782312"/>
-            <a:ext cx="2340864" cy="347472"/>
-          </a:xfrm>
-          <a:prstGeom prst="rect">
-            <a:avLst/>
-          </a:prstGeom>
-          <a:noFill/>
-        </p:spPr>
-        <p:txBody>
-          <a:bodyPr wrap="square" lIns="32004" rIns="32004" tIns="4572" bIns="4572" anchor="ctr">
-            <a:spAutoFit/>
-          </a:bodyPr>
-          <a:lstStyle/>
-          <a:p>
-            <a:pPr algn="ctr">
-              <a:lnSpc>
-                <a:spcPct val="104000"/>
-              </a:lnSpc>
-              <a:spcBef>
-                <a:spcPts val="0"/>
-              </a:spcBef>
-              <a:spcAft>
-                <a:spcPts val="0"/>
-              </a:spcAft>
-            </a:pPr>
-            <a:r>
-              <a:rPr sz="2100" b="1">
-                <a:solidFill>
-                  <a:srgbClr val="147E84"/>
-                </a:solidFill>
-                <a:latin typeface="Noto Sans CJK SC"/>
-                <a:ea typeface="Noto Sans CJK SC"/>
-              </a:rPr>
-              <a:t>振动波形窗口</a:t>
-            </a:r>
-          </a:p>
-        </p:txBody>
-      </p:sp>
-      <p:sp>
-        <p:nvSpPr>
-          <p:cNvPr id="29" name="TextBox 28"/>
-          <p:cNvSpPr txBox="1"/>
-          <p:nvPr/>
-        </p:nvSpPr>
-        <p:spPr>
-          <a:xfrm>
-            <a:off x="795528" y="5157216"/>
-            <a:ext cx="2340864" cy="548640"/>
-          </a:xfrm>
-          <a:prstGeom prst="rect">
-            <a:avLst/>
-          </a:prstGeom>
-          <a:noFill/>
-        </p:spPr>
-        <p:txBody>
-          <a:bodyPr wrap="square" lIns="32004" rIns="32004" tIns="4572" bIns="4572" anchor="ctr">
-            <a:spAutoFit/>
-          </a:bodyPr>
-          <a:lstStyle/>
-          <a:p>
-            <a:pPr algn="ctr">
-              <a:lnSpc>
-                <a:spcPct val="104000"/>
-              </a:lnSpc>
-              <a:spcBef>
-                <a:spcPts val="0"/>
-              </a:spcBef>
-              <a:spcAft>
-                <a:spcPts val="0"/>
-              </a:spcAft>
-            </a:pPr>
-            <a:r>
-              <a:rPr sz="2100" b="0">
+              <a:rPr sz="2300" b="0">
                 <a:solidFill>
                   <a:srgbClr val="243E50"/>
                 </a:solidFill>
                 <a:latin typeface="Noto Sans CJK SC"/>
                 <a:ea typeface="Noto Sans CJK SC"/>
               </a:rPr>
-              <a:t>经降噪与标准化</a:t>
-            </a:r>
-          </a:p>
-        </p:txBody>
-      </p:sp>
-      <p:sp>
-        <p:nvSpPr>
-          <p:cNvPr id="30" name="Right Arrow 29"/>
-          <p:cNvSpPr/>
+              <a:t>同一工况下持续异常，则需要进一步检查。</a:t>
+            </a:r>
+          </a:p>
+        </p:txBody>
+      </p:sp>
+      <p:sp>
+        <p:nvSpPr>
+          <p:cNvPr id="23" name="TextBox 22"/>
+          <p:cNvSpPr txBox="1"/>
           <p:nvPr/>
         </p:nvSpPr>
         <p:spPr>
           <a:xfrm>
-            <a:off x="3259836" y="5152644"/>
-            <a:ext cx="164592" cy="182880"/>
-          </a:xfrm>
-          <a:prstGeom prst="rightArrow">
-            <a:avLst/>
-          </a:prstGeom>
-          <a:solidFill>
-            <a:srgbClr val="147E84"/>
-          </a:solidFill>
-          <a:ln>
-            <a:noFill/>
-          </a:ln>
-        </p:spPr>
-        <p:style>
-          <a:lnRef idx="1">
-            <a:schemeClr val="accent1"/>
-          </a:lnRef>
-          <a:fillRef idx="3">
-            <a:schemeClr val="accent1"/>
-          </a:fillRef>
-          <a:effectRef idx="2">
-            <a:schemeClr val="accent1"/>
-          </a:effectRef>
-          <a:fontRef idx="minor">
-            <a:schemeClr val="lt1"/>
-          </a:fontRef>
-        </p:style>
-        <p:txBody>
-          <a:bodyPr rtlCol="0" anchor="ctr"/>
-          <a:lstStyle/>
-          <a:p>
-            <a:pPr algn="ctr"/>
-          </a:p>
-        </p:txBody>
-      </p:sp>
-      <p:sp>
-        <p:nvSpPr>
-          <p:cNvPr id="31" name="Rounded Rectangle 30"/>
-          <p:cNvSpPr/>
-          <p:nvPr/>
-        </p:nvSpPr>
-        <p:spPr>
-          <a:xfrm>
-            <a:off x="3483863" y="4727448"/>
-            <a:ext cx="2468880" cy="1033271"/>
-          </a:xfrm>
-          <a:prstGeom prst="roundRect">
-            <a:avLst/>
-          </a:prstGeom>
-          <a:solidFill>
-            <a:srgbClr val="E5F2F1"/>
-          </a:solidFill>
-          <a:ln>
-            <a:noFill/>
-          </a:ln>
-        </p:spPr>
-        <p:style>
-          <a:lnRef idx="1">
-            <a:schemeClr val="accent1"/>
-          </a:lnRef>
-          <a:fillRef idx="3">
-            <a:schemeClr val="accent1"/>
-          </a:fillRef>
-          <a:effectRef idx="2">
-            <a:schemeClr val="accent1"/>
-          </a:effectRef>
-          <a:fontRef idx="minor">
-            <a:schemeClr val="lt1"/>
-          </a:fontRef>
-        </p:style>
-        <p:txBody>
-          <a:bodyPr rtlCol="0" anchor="ctr"/>
-          <a:lstStyle/>
-          <a:p>
-            <a:pPr algn="ctr"/>
-          </a:p>
-        </p:txBody>
-      </p:sp>
-      <p:sp>
-        <p:nvSpPr>
-          <p:cNvPr id="32" name="TextBox 31"/>
-          <p:cNvSpPr txBox="1"/>
-          <p:nvPr/>
-        </p:nvSpPr>
-        <p:spPr>
-          <a:xfrm>
-            <a:off x="3547871" y="4782312"/>
-            <a:ext cx="2340864" cy="347472"/>
-          </a:xfrm>
-          <a:prstGeom prst="rect">
-            <a:avLst/>
-          </a:prstGeom>
-          <a:noFill/>
-        </p:spPr>
-        <p:txBody>
-          <a:bodyPr wrap="square" lIns="32004" rIns="32004" tIns="4572" bIns="4572" anchor="ctr">
-            <a:spAutoFit/>
-          </a:bodyPr>
-          <a:lstStyle/>
-          <a:p>
-            <a:pPr algn="ctr">
-              <a:lnSpc>
-                <a:spcPct val="104000"/>
-              </a:lnSpc>
-              <a:spcBef>
-                <a:spcPts val="0"/>
-              </a:spcBef>
-              <a:spcAft>
-                <a:spcPts val="0"/>
-              </a:spcAft>
-            </a:pPr>
-            <a:r>
-              <a:rPr sz="2100" b="1">
-                <a:solidFill>
-                  <a:srgbClr val="147E84"/>
-                </a:solidFill>
-                <a:latin typeface="Noto Sans CJK SC"/>
-                <a:ea typeface="Noto Sans CJK SC"/>
-              </a:rPr>
-              <a:t>轻量 1D CNN</a:t>
-            </a:r>
-          </a:p>
-        </p:txBody>
-      </p:sp>
-      <p:sp>
-        <p:nvSpPr>
-          <p:cNvPr id="33" name="TextBox 32"/>
-          <p:cNvSpPr txBox="1"/>
-          <p:nvPr/>
-        </p:nvSpPr>
-        <p:spPr>
-          <a:xfrm>
-            <a:off x="3547871" y="5157216"/>
-            <a:ext cx="2340864" cy="548640"/>
-          </a:xfrm>
-          <a:prstGeom prst="rect">
-            <a:avLst/>
-          </a:prstGeom>
-          <a:noFill/>
-        </p:spPr>
-        <p:txBody>
-          <a:bodyPr wrap="square" lIns="32004" rIns="32004" tIns="4572" bIns="4572" anchor="ctr">
-            <a:spAutoFit/>
-          </a:bodyPr>
-          <a:lstStyle/>
-          <a:p>
-            <a:pPr algn="ctr">
-              <a:lnSpc>
-                <a:spcPct val="104000"/>
-              </a:lnSpc>
-              <a:spcBef>
-                <a:spcPts val="0"/>
-              </a:spcBef>
-              <a:spcAft>
-                <a:spcPts val="0"/>
-              </a:spcAft>
-            </a:pPr>
-            <a:r>
-              <a:rPr sz="2100" b="0">
-                <a:solidFill>
-                  <a:srgbClr val="243E50"/>
-                </a:solidFill>
-                <a:latin typeface="Noto Sans CJK SC"/>
-                <a:ea typeface="Noto Sans CJK SC"/>
-              </a:rPr>
-              <a:t>提取波形特征</a:t>
-            </a:r>
-          </a:p>
-        </p:txBody>
-      </p:sp>
-      <p:sp>
-        <p:nvSpPr>
-          <p:cNvPr id="34" name="Right Arrow 33"/>
-          <p:cNvSpPr/>
-          <p:nvPr/>
-        </p:nvSpPr>
-        <p:spPr>
-          <a:xfrm>
-            <a:off x="6012180" y="5152644"/>
-            <a:ext cx="164592" cy="182880"/>
-          </a:xfrm>
-          <a:prstGeom prst="rightArrow">
-            <a:avLst/>
-          </a:prstGeom>
-          <a:solidFill>
-            <a:srgbClr val="147E84"/>
-          </a:solidFill>
-          <a:ln>
-            <a:noFill/>
-          </a:ln>
-        </p:spPr>
-        <p:style>
-          <a:lnRef idx="1">
-            <a:schemeClr val="accent1"/>
-          </a:lnRef>
-          <a:fillRef idx="3">
-            <a:schemeClr val="accent1"/>
-          </a:fillRef>
-          <a:effectRef idx="2">
-            <a:schemeClr val="accent1"/>
-          </a:effectRef>
-          <a:fontRef idx="minor">
-            <a:schemeClr val="lt1"/>
-          </a:fontRef>
-        </p:style>
-        <p:txBody>
-          <a:bodyPr rtlCol="0" anchor="ctr"/>
-          <a:lstStyle/>
-          <a:p>
-            <a:pPr algn="ctr"/>
-          </a:p>
-        </p:txBody>
-      </p:sp>
-      <p:sp>
-        <p:nvSpPr>
-          <p:cNvPr id="35" name="Rounded Rectangle 34"/>
-          <p:cNvSpPr/>
-          <p:nvPr/>
-        </p:nvSpPr>
-        <p:spPr>
-          <a:xfrm>
-            <a:off x="6236207" y="4727448"/>
-            <a:ext cx="2468880" cy="1033271"/>
-          </a:xfrm>
-          <a:prstGeom prst="roundRect">
-            <a:avLst/>
-          </a:prstGeom>
-          <a:solidFill>
-            <a:srgbClr val="E5F2F1"/>
-          </a:solidFill>
-          <a:ln>
-            <a:noFill/>
-          </a:ln>
-        </p:spPr>
-        <p:style>
-          <a:lnRef idx="1">
-            <a:schemeClr val="accent1"/>
-          </a:lnRef>
-          <a:fillRef idx="3">
-            <a:schemeClr val="accent1"/>
-          </a:fillRef>
-          <a:effectRef idx="2">
-            <a:schemeClr val="accent1"/>
-          </a:effectRef>
-          <a:fontRef idx="minor">
-            <a:schemeClr val="lt1"/>
-          </a:fontRef>
-        </p:style>
-        <p:txBody>
-          <a:bodyPr rtlCol="0" anchor="ctr"/>
-          <a:lstStyle/>
-          <a:p>
-            <a:pPr algn="ctr"/>
-          </a:p>
-        </p:txBody>
-      </p:sp>
-      <p:sp>
-        <p:nvSpPr>
-          <p:cNvPr id="36" name="TextBox 35"/>
-          <p:cNvSpPr txBox="1"/>
-          <p:nvPr/>
-        </p:nvSpPr>
-        <p:spPr>
-          <a:xfrm>
-            <a:off x="6300216" y="4782312"/>
-            <a:ext cx="2340864" cy="347472"/>
-          </a:xfrm>
-          <a:prstGeom prst="rect">
-            <a:avLst/>
-          </a:prstGeom>
-          <a:noFill/>
-        </p:spPr>
-        <p:txBody>
-          <a:bodyPr wrap="square" lIns="32004" rIns="32004" tIns="4572" bIns="4572" anchor="ctr">
-            <a:spAutoFit/>
-          </a:bodyPr>
-          <a:lstStyle/>
-          <a:p>
-            <a:pPr algn="ctr">
-              <a:lnSpc>
-                <a:spcPct val="104000"/>
-              </a:lnSpc>
-              <a:spcBef>
-                <a:spcPts val="0"/>
-              </a:spcBef>
-              <a:spcAft>
-                <a:spcPts val="0"/>
-              </a:spcAft>
-            </a:pPr>
-            <a:r>
-              <a:rPr sz="2100" b="1">
-                <a:solidFill>
-                  <a:srgbClr val="147E84"/>
-                </a:solidFill>
-                <a:latin typeface="Noto Sans CJK SC"/>
-                <a:ea typeface="Noto Sans CJK SC"/>
-              </a:rPr>
-              <a:t>线性注意力</a:t>
-            </a:r>
-          </a:p>
-        </p:txBody>
-      </p:sp>
-      <p:sp>
-        <p:nvSpPr>
-          <p:cNvPr id="37" name="TextBox 36"/>
-          <p:cNvSpPr txBox="1"/>
-          <p:nvPr/>
-        </p:nvSpPr>
-        <p:spPr>
-          <a:xfrm>
-            <a:off x="6300216" y="5157216"/>
-            <a:ext cx="2340864" cy="548640"/>
-          </a:xfrm>
-          <a:prstGeom prst="rect">
-            <a:avLst/>
-          </a:prstGeom>
-          <a:noFill/>
-        </p:spPr>
-        <p:txBody>
-          <a:bodyPr wrap="square" lIns="32004" rIns="32004" tIns="4572" bIns="4572" anchor="ctr">
-            <a:spAutoFit/>
-          </a:bodyPr>
-          <a:lstStyle/>
-          <a:p>
-            <a:pPr algn="ctr">
-              <a:lnSpc>
-                <a:spcPct val="104000"/>
-              </a:lnSpc>
-              <a:spcBef>
-                <a:spcPts val="0"/>
-              </a:spcBef>
-              <a:spcAft>
-                <a:spcPts val="0"/>
-              </a:spcAft>
-            </a:pPr>
-            <a:r>
-              <a:rPr sz="2100" b="0">
-                <a:solidFill>
-                  <a:srgbClr val="243E50"/>
-                </a:solidFill>
-                <a:latin typeface="Noto Sans CJK SC"/>
-                <a:ea typeface="Noto Sans CJK SC"/>
-              </a:rPr>
-              <a:t>关联窗口内位置</a:t>
-            </a:r>
-          </a:p>
-        </p:txBody>
-      </p:sp>
-      <p:sp>
-        <p:nvSpPr>
-          <p:cNvPr id="38" name="Right Arrow 37"/>
-          <p:cNvSpPr/>
-          <p:nvPr/>
-        </p:nvSpPr>
-        <p:spPr>
-          <a:xfrm>
-            <a:off x="8764524" y="5152644"/>
-            <a:ext cx="164592" cy="182880"/>
-          </a:xfrm>
-          <a:prstGeom prst="rightArrow">
-            <a:avLst/>
-          </a:prstGeom>
-          <a:solidFill>
-            <a:srgbClr val="147E84"/>
-          </a:solidFill>
-          <a:ln>
-            <a:noFill/>
-          </a:ln>
-        </p:spPr>
-        <p:style>
-          <a:lnRef idx="1">
-            <a:schemeClr val="accent1"/>
-          </a:lnRef>
-          <a:fillRef idx="3">
-            <a:schemeClr val="accent1"/>
-          </a:fillRef>
-          <a:effectRef idx="2">
-            <a:schemeClr val="accent1"/>
-          </a:effectRef>
-          <a:fontRef idx="minor">
-            <a:schemeClr val="lt1"/>
-          </a:fontRef>
-        </p:style>
-        <p:txBody>
-          <a:bodyPr rtlCol="0" anchor="ctr"/>
-          <a:lstStyle/>
-          <a:p>
-            <a:pPr algn="ctr"/>
-          </a:p>
-        </p:txBody>
-      </p:sp>
-      <p:sp>
-        <p:nvSpPr>
-          <p:cNvPr id="39" name="Rounded Rectangle 38"/>
-          <p:cNvSpPr/>
-          <p:nvPr/>
-        </p:nvSpPr>
-        <p:spPr>
-          <a:xfrm>
-            <a:off x="8988552" y="4727448"/>
-            <a:ext cx="2468880" cy="1033271"/>
-          </a:xfrm>
-          <a:prstGeom prst="roundRect">
-            <a:avLst/>
-          </a:prstGeom>
-          <a:solidFill>
-            <a:srgbClr val="E5F2F1"/>
-          </a:solidFill>
-          <a:ln>
-            <a:noFill/>
-          </a:ln>
-        </p:spPr>
-        <p:style>
-          <a:lnRef idx="1">
-            <a:schemeClr val="accent1"/>
-          </a:lnRef>
-          <a:fillRef idx="3">
-            <a:schemeClr val="accent1"/>
-          </a:fillRef>
-          <a:effectRef idx="2">
-            <a:schemeClr val="accent1"/>
-          </a:effectRef>
-          <a:fontRef idx="minor">
-            <a:schemeClr val="lt1"/>
-          </a:fontRef>
-        </p:style>
-        <p:txBody>
-          <a:bodyPr rtlCol="0" anchor="ctr"/>
-          <a:lstStyle/>
-          <a:p>
-            <a:pPr algn="ctr"/>
-          </a:p>
-        </p:txBody>
-      </p:sp>
-      <p:sp>
-        <p:nvSpPr>
-          <p:cNvPr id="40" name="TextBox 39"/>
-          <p:cNvSpPr txBox="1"/>
-          <p:nvPr/>
-        </p:nvSpPr>
-        <p:spPr>
-          <a:xfrm>
-            <a:off x="9052560" y="4782312"/>
-            <a:ext cx="2340864" cy="347472"/>
-          </a:xfrm>
-          <a:prstGeom prst="rect">
-            <a:avLst/>
-          </a:prstGeom>
-          <a:noFill/>
-        </p:spPr>
-        <p:txBody>
-          <a:bodyPr wrap="square" lIns="32004" rIns="32004" tIns="4572" bIns="4572" anchor="ctr">
-            <a:spAutoFit/>
-          </a:bodyPr>
-          <a:lstStyle/>
-          <a:p>
-            <a:pPr algn="ctr">
-              <a:lnSpc>
-                <a:spcPct val="104000"/>
-              </a:lnSpc>
-              <a:spcBef>
-                <a:spcPts val="0"/>
-              </a:spcBef>
-              <a:spcAft>
-                <a:spcPts val="0"/>
-              </a:spcAft>
-            </a:pPr>
-            <a:r>
-              <a:rPr sz="2100" b="1">
-                <a:solidFill>
-                  <a:srgbClr val="147E84"/>
-                </a:solidFill>
-                <a:latin typeface="Noto Sans CJK SC"/>
-                <a:ea typeface="Noto Sans CJK SC"/>
-              </a:rPr>
-              <a:t>故障部位分类</a:t>
-            </a:r>
-          </a:p>
-        </p:txBody>
-      </p:sp>
-      <p:sp>
-        <p:nvSpPr>
-          <p:cNvPr id="41" name="TextBox 40"/>
-          <p:cNvSpPr txBox="1"/>
-          <p:nvPr/>
-        </p:nvSpPr>
-        <p:spPr>
-          <a:xfrm>
-            <a:off x="9052560" y="5157216"/>
-            <a:ext cx="2340864" cy="548640"/>
-          </a:xfrm>
-          <a:prstGeom prst="rect">
-            <a:avLst/>
-          </a:prstGeom>
-          <a:noFill/>
-        </p:spPr>
-        <p:txBody>
-          <a:bodyPr wrap="square" lIns="32004" rIns="32004" tIns="4572" bIns="4572" anchor="ctr">
-            <a:spAutoFit/>
-          </a:bodyPr>
-          <a:lstStyle/>
-          <a:p>
-            <a:pPr algn="ctr">
-              <a:lnSpc>
-                <a:spcPct val="104000"/>
-              </a:lnSpc>
-              <a:spcBef>
-                <a:spcPts val="0"/>
-              </a:spcBef>
-              <a:spcAft>
-                <a:spcPts val="0"/>
-              </a:spcAft>
-            </a:pPr>
-            <a:r>
-              <a:rPr sz="2100" b="0">
-                <a:solidFill>
-                  <a:srgbClr val="243E50"/>
-                </a:solidFill>
-                <a:latin typeface="Noto Sans CJK SC"/>
-                <a:ea typeface="Noto Sans CJK SC"/>
-              </a:rPr>
-              <a:t>正常／内圈</a:t>
-            </a:r>
-          </a:p>
-          <a:p>
-            <a:pPr algn="ctr">
-              <a:lnSpc>
-                <a:spcPct val="104000"/>
-              </a:lnSpc>
-              <a:spcBef>
-                <a:spcPts val="0"/>
-              </a:spcBef>
-              <a:spcAft>
-                <a:spcPts val="0"/>
-              </a:spcAft>
-            </a:pPr>
-            <a:r>
-              <a:rPr sz="2100" b="0">
-                <a:solidFill>
-                  <a:srgbClr val="243E50"/>
-                </a:solidFill>
-                <a:latin typeface="Noto Sans CJK SC"/>
-                <a:ea typeface="Noto Sans CJK SC"/>
-              </a:rPr>
-              <a:t>滚动体／外圈</a:t>
-            </a:r>
-          </a:p>
-        </p:txBody>
-      </p:sp>
-      <p:sp>
-        <p:nvSpPr>
-          <p:cNvPr id="42" name="Rounded Rectangle 41"/>
-          <p:cNvSpPr/>
-          <p:nvPr/>
-        </p:nvSpPr>
-        <p:spPr>
-          <a:xfrm>
-            <a:off x="731520" y="6053328"/>
-            <a:ext cx="10725912" cy="457200"/>
-          </a:xfrm>
-          <a:prstGeom prst="roundRect">
-            <a:avLst/>
-          </a:prstGeom>
-          <a:solidFill>
-            <a:srgbClr val="F0F5F8"/>
-          </a:solidFill>
-          <a:ln>
-            <a:noFill/>
-          </a:ln>
-        </p:spPr>
-        <p:style>
-          <a:lnRef idx="1">
-            <a:schemeClr val="accent1"/>
-          </a:lnRef>
-          <a:fillRef idx="3">
-            <a:schemeClr val="accent1"/>
-          </a:fillRef>
-          <a:effectRef idx="2">
-            <a:schemeClr val="accent1"/>
-          </a:effectRef>
-          <a:fontRef idx="minor">
-            <a:schemeClr val="lt1"/>
-          </a:fontRef>
-        </p:style>
-        <p:txBody>
-          <a:bodyPr rtlCol="0" anchor="ctr"/>
-          <a:lstStyle/>
-          <a:p>
-            <a:pPr algn="ctr"/>
-          </a:p>
-        </p:txBody>
-      </p:sp>
-      <p:sp>
-        <p:nvSpPr>
-          <p:cNvPr id="43" name="TextBox 42"/>
-          <p:cNvSpPr txBox="1"/>
-          <p:nvPr/>
-        </p:nvSpPr>
-        <p:spPr>
-          <a:xfrm>
-            <a:off x="896112" y="6080760"/>
-            <a:ext cx="10396728" cy="402336"/>
+            <a:off x="758952" y="5815584"/>
+            <a:ext cx="10671048" cy="347472"/>
           </a:xfrm>
           <a:prstGeom prst="rect">
             <a:avLst/>
@@ -5478,14 +4695,60 @@
               </a:spcAft>
             </a:pPr>
             <a:r>
-              <a:rPr sz="2100" b="1">
+              <a:rPr sz="2100" b="0">
                 <a:solidFill>
                   <a:srgbClr val="15334A"/>
                 </a:solidFill>
                 <a:latin typeface="Noto Sans CJK SC"/>
                 <a:ea typeface="Noto Sans CJK SC"/>
               </a:rPr>
-              <a:t>下一步：接入真实多源数据，重训并验证健康等级与寿命预测</a:t>
+              <a:t>当前：仿真结果已接入网页；公开轴承数据已用于故障部位分类。</a:t>
+            </a:r>
+          </a:p>
+        </p:txBody>
+      </p:sp>
+      <p:sp>
+        <p:nvSpPr>
+          <p:cNvPr id="24" name="TextBox 23"/>
+          <p:cNvSpPr txBox="1"/>
+          <p:nvPr/>
+        </p:nvSpPr>
+        <p:spPr>
+          <a:xfrm>
+            <a:off x="758952" y="6254496"/>
+            <a:ext cx="10671048" cy="347472"/>
+          </a:xfrm>
+          <a:prstGeom prst="rect">
+            <a:avLst/>
+          </a:prstGeom>
+          <a:noFill/>
+        </p:spPr>
+        <p:txBody>
+          <a:bodyPr wrap="square" lIns="32004" rIns="32004" tIns="4572" bIns="4572" anchor="ctr">
+            <a:spAutoFit/>
+          </a:bodyPr>
+          <a:lstStyle/>
+          <a:p>
+            <a:pPr algn="l">
+              <a:lnSpc>
+                <a:spcPct val="104000"/>
+              </a:lnSpc>
+              <a:spcBef>
+                <a:spcPts val="0"/>
+              </a:spcBef>
+              <a:spcAft>
+                <a:spcPts val="0"/>
+              </a:spcAft>
+            </a:pPr>
+            <a:r>
+              <a:rPr sz="2100" b="0">
+                <a:solidFill>
+                  <a:srgbClr val="15334A"/>
+                </a:solidFill>
+                <a:latin typeface="Noto Sans CJK SC"/>
+                <a:ea typeface="Noto Sans CJK SC"/>
+              </a:rPr>
+              <a:t>后续：采集真实多源数据，验证健康等级与寿命预测。</a:t>
             </a:r>
           </a:p>
         </p:txBody>

</xml_diff>